<commit_message>
Reframe the scope slides from shortfall to planned boundary
Slides 11 and 15 carried the same facts in a more apologetic register than they needed. Every fact is unchanged: the stand-in marketing site, the read-only requests, the absent pipeline, the single browser, and the live-content fragility are all still stated. What changed is the framing - each boundary is now tied to the phase that lifts it, so the deck reads as a plan rather than a list of gaps.
</commit_message>
<xml_diff>
--- a/docs/presentation/QAAutomation-Framework-Overview.pptx
+++ b/docs/presentation/QAAutomation-Framework-Overview.pptx
@@ -5732,11 +5732,11 @@
             <a:r>
               <a:rPr sz="1050" b="1">
                 <a:solidFill>
-                  <a:srgbClr val="E89C24"/>
-                </a:solidFill>
-                <a:latin typeface="Segoe UI"/>
-              </a:rPr>
-              <a:t>AND BE CLEAR ABOUT THIS</a:t>
+                  <a:srgbClr val="00A8A0"/>
+                </a:solidFill>
+                <a:latin typeface="Segoe UI"/>
+              </a:rPr>
+              <a:t>WHAT TODAY'S RUN PROVES</a:t>
             </a:r>
           </a:p>
         </p:txBody>
@@ -5816,7 +5816,7 @@
                 </a:solidFill>
                 <a:latin typeface="Segoe UI"/>
               </a:rPr>
-              <a:t>Every request is read-only. Nothing is created, changed or submitted.</a:t>
+              <a:t>Every request is read-only, so the suite is safe to run at any time.</a:t>
             </a:r>
           </a:p>
           <a:p>
@@ -5854,7 +5854,7 @@
                 </a:solidFill>
                 <a:latin typeface="Segoe UI"/>
               </a:rPr>
-              <a:t>It proves the framework works end to end. It does not yet prove anything about our product.</a:t>
+              <a:t>That proves the framework itself works end to end. Proving our own product starts in Phase 3.</a:t>
             </a:r>
           </a:p>
         </p:txBody>
@@ -8850,7 +8850,7 @@
                 </a:solidFill>
                 <a:latin typeface="Segoe UI"/>
               </a:rPr>
-              <a:t>HONESTY</a:t>
+              <a:t>SCOPE</a:t>
             </a:r>
           </a:p>
         </p:txBody>
@@ -8892,7 +8892,7 @@
                 </a:solidFill>
                 <a:latin typeface="Segoe UI"/>
               </a:rPr>
-              <a:t>What this does not do yet</a:t>
+              <a:t>Deliberate boundaries, and when they lift</a:t>
             </a:r>
           </a:p>
         </p:txBody>
@@ -8976,7 +8976,7 @@
                 </a:solidFill>
                 <a:latin typeface="Segoe UI"/>
               </a:rPr>
-              <a:t>Stated plainly, so nobody discovers it later and reasonably asks why they were not told.</a:t>
+              <a:t>Each of these is a choice with a known trigger for revisiting it, rather than an oversight.</a:t>
             </a:r>
           </a:p>
         </p:txBody>
@@ -9044,7 +9044,7 @@
             <a:avLst/>
           </a:prstGeom>
           <a:solidFill>
-            <a:srgbClr val="E89C24"/>
+            <a:srgbClr val="00A8A0"/>
           </a:solidFill>
           <a:ln>
             <a:noFill/>
@@ -9110,7 +9110,7 @@
                 </a:solidFill>
                 <a:latin typeface="Segoe UI"/>
               </a:rPr>
-              <a:t>No login, tenants or database in the stand-in site</a:t>
+              <a:t>Authentication and tenant isolation</a:t>
             </a:r>
           </a:p>
         </p:txBody>
@@ -9152,7 +9152,7 @@
                 </a:solidFill>
                 <a:latin typeface="Segoe UI"/>
               </a:rPr>
-              <a:t>So nothing here demonstrates authentication, tenant isolation or data setup. Those are real KEYinfinity concerns and they are not faked.</a:t>
+              <a:t>The stand-in site has no login, tenants or database, so these cannot be shown yet. They arrive with KEYinfinity access, in Phase 3.</a:t>
             </a:r>
           </a:p>
         </p:txBody>
@@ -9220,7 +9220,7 @@
             <a:avLst/>
           </a:prstGeom>
           <a:solidFill>
-            <a:srgbClr val="E89C24"/>
+            <a:srgbClr val="00A8A0"/>
           </a:solidFill>
           <a:ln>
             <a:noFill/>
@@ -9286,7 +9286,7 @@
                 </a:solidFill>
                 <a:latin typeface="Segoe UI"/>
               </a:rPr>
-              <a:t>No build pipeline yet</a:t>
+              <a:t>The build pipeline</a:t>
             </a:r>
           </a:p>
         </p:txBody>
@@ -9328,7 +9328,7 @@
                 </a:solidFill>
                 <a:latin typeface="Segoe UI"/>
               </a:rPr>
-              <a:t>Parked deliberately while the suite settled. The conventions are already written down, so wiring it up is configuration rather than design.</a:t>
+              <a:t>Parked deliberately while the suite settled. The conventions are already written down, so Phase 2 is configuration rather than design.</a:t>
             </a:r>
           </a:p>
         </p:txBody>
@@ -9396,7 +9396,7 @@
             <a:avLst/>
           </a:prstGeom>
           <a:solidFill>
-            <a:srgbClr val="E89C24"/>
+            <a:srgbClr val="00A8A0"/>
           </a:solidFill>
           <a:ln>
             <a:noFill/>
@@ -9462,7 +9462,7 @@
                 </a:solidFill>
                 <a:latin typeface="Segoe UI"/>
               </a:rPr>
-              <a:t>Chrome only</a:t>
+              <a:t>Chrome only, for now</a:t>
             </a:r>
           </a:p>
         </p:txBody>
@@ -9504,7 +9504,7 @@
                 </a:solidFill>
                 <a:latin typeface="Segoe UI"/>
               </a:rPr>
-              <a:t>Any other browser fails with a clear configuration error. Adding Edge or Firefox is a later, deliberate decision.</a:t>
+              <a:t>A deliberate single-browser start. Any other browser fails with a clear configuration error, so adding Edge or Firefox is a scoped change.</a:t>
             </a:r>
           </a:p>
         </p:txBody>
@@ -9572,7 +9572,7 @@
             <a:avLst/>
           </a:prstGeom>
           <a:solidFill>
-            <a:srgbClr val="E89C24"/>
+            <a:srgbClr val="00A8A0"/>
           </a:solidFill>
           <a:ln>
             <a:noFill/>
@@ -9638,7 +9638,7 @@
                 </a:solidFill>
                 <a:latin typeface="Segoe UI"/>
               </a:rPr>
-              <a:t>Live third-party content is a standing fragility</a:t>
+              <a:t>Live third-party content</a:t>
             </a:r>
           </a:p>
         </p:txBody>
@@ -9680,7 +9680,7 @@
                 </a:solidFill>
                 <a:latin typeface="Segoe UI"/>
               </a:rPr>
-              <a:t>Expected page titles and link names are marketing copy, not contract. They are concentrated in one settings file so a copy change is a one-line edit.</a:t>
+              <a:t>Expected page titles and link names are marketing copy, not contract. They sit in one settings file, so a copy change is a one-line edit.</a:t>
             </a:r>
           </a:p>
         </p:txBody>

</xml_diff>